<commit_message>
Re-export the 29 Aug decks with reading-order entrances
Same exporter fix as the previous commit: unlisted animated groups now
follow the nearest listed order, so headlines and carriers enter before
the numbered body. Re-exported attention, song diancha, wave
interference, china telecom, pritzker quick and kubernetes; SVGs,
sidecars and thumbnails unchanged.

Co-Authored-By: Claude Fable 5.1 <noreply@anthropic.com>
Claude-Session: https://claude.ai/code/session_012NoFEKH3he3B5mkTi8ZQiE
</commit_message>
<xml_diff>
--- a/examples/ppt169_china_telecom_2025/exports/china_telecom_2025.pptx
+++ b/examples/ppt169_china_telecom_2025/exports/china_telecom_2025.pptx
@@ -1527,7 +1527,7 @@
           </a:lstStyle>
           <a:p>
             <a:pPr algn="l"/>
-            <a:fld id="{FEE4D02C-A6EE-406A-8EE3-559579466B3E}" type="datetimeFigureOut">
+            <a:fld id="{BF5F6FCF-1966-4AE7-A7BF-85C2B43CF756}" type="datetimeFigureOut">
               <a:rPr lang="zh-CN" sz="1120" dirty="0">
                 <a:solidFill>
                   <a:srgbClr val="6B7280"/>
@@ -1545,7 +1545,7 @@
     </p:spTree>
     <p:extLst>
       <p:ext uri="{BB962C8B-B14F-4D97-AF65-F5344CB8AC3E}">
-        <p14:creationId val="975818304"/>
+        <p14:creationId val="3621819676"/>
       </p:ext>
     </p:extLst>
   </p:cSld>
@@ -2528,7 +2528,7 @@
           </a:lstStyle>
           <a:p>
             <a:pPr algn="r"/>
-            <a:fld id="{F3A02024-E6D6-4C41-BC03-B17F4E84C6A3}" type="slidenum">
+            <a:fld id="{C2E6BDF8-0DF1-4279-9F2B-EA99ACC67F14}" type="slidenum">
               <a:rPr lang="en-US" sz="980" dirty="0">
                 <a:solidFill>
                   <a:srgbClr val="6B7280"/>
@@ -2546,7 +2546,7 @@
     </p:spTree>
     <p:extLst>
       <p:ext uri="{BB962C8B-B14F-4D97-AF65-F5344CB8AC3E}">
-        <p14:creationId val="2141417365"/>
+        <p14:creationId val="605664052"/>
       </p:ext>
     </p:extLst>
   </p:cSld>
@@ -2992,7 +2992,7 @@
     </p:spTree>
     <p:extLst>
       <p:ext uri="{BB962C8B-B14F-4D97-AF65-F5344CB8AC3E}">
-        <p14:creationId val="1127696565"/>
+        <p14:creationId val="897026354"/>
       </p:ext>
     </p:extLst>
   </p:cSld>
@@ -3328,7 +3328,7 @@
           </a:lstStyle>
           <a:p>
             <a:pPr algn="r"/>
-            <a:fld id="{02656CDB-6E1E-40CE-A3A0-3AF7E8D3C9DD}" type="slidenum">
+            <a:fld id="{10793D74-4946-4AB6-9CE1-E7A40CB4676C}" type="slidenum">
               <a:rPr lang="en-US" sz="980" dirty="0">
                 <a:solidFill>
                   <a:srgbClr val="6B7280"/>
@@ -3346,7 +3346,7 @@
     </p:spTree>
     <p:extLst>
       <p:ext uri="{BB962C8B-B14F-4D97-AF65-F5344CB8AC3E}">
-        <p14:creationId val="1470698371"/>
+        <p14:creationId val="3615897115"/>
       </p:ext>
     </p:extLst>
   </p:cSld>
@@ -3707,7 +3707,7 @@
           </a:lstStyle>
           <a:p>
             <a:pPr algn="r"/>
-            <a:fld id="{C967A108-118B-4DB0-B23E-235C6129167A}" type="slidenum">
+            <a:fld id="{BE97FB3D-1B3B-4E90-A373-FAD9CC4195ED}" type="slidenum">
               <a:rPr lang="en-US" sz="980" dirty="0">
                 <a:solidFill>
                   <a:srgbClr val="FFFFFF"/>
@@ -3725,7 +3725,7 @@
     </p:spTree>
     <p:extLst>
       <p:ext uri="{BB962C8B-B14F-4D97-AF65-F5344CB8AC3E}">
-        <p14:creationId val="3061730961"/>
+        <p14:creationId val="3085127790"/>
       </p:ext>
     </p:extLst>
   </p:cSld>
@@ -4272,7 +4272,7 @@
     </p:spTree>
     <p:extLst>
       <p:ext uri="{BB962C8B-B14F-4D97-AF65-F5344CB8AC3E}">
-        <p14:creationId val="411975423"/>
+        <p14:creationId val="408241295"/>
       </p:ext>
     </p:extLst>
   </p:cSld>
@@ -6903,7 +6903,7 @@
           <a:lstStyle/>
           <a:p>
             <a:pPr algn="r"/>
-            <a:fld id="{2C929761-D0AF-4FB6-99A8-F4A205524043}" type="slidenum">
+            <a:fld id="{CE08A4B2-6BE8-42F3-B69C-FA4AB14D774D}" type="slidenum">
               <a:rPr lang="en-US" sz="980" dirty="0">
                 <a:solidFill>
                   <a:srgbClr val="6B7280"/>
@@ -9470,7 +9470,7 @@
           <a:lstStyle/>
           <a:p>
             <a:pPr algn="r"/>
-            <a:fld id="{2C929761-D0AF-4FB6-99A8-F4A205524043}" type="slidenum">
+            <a:fld id="{CE08A4B2-6BE8-42F3-B69C-FA4AB14D774D}" type="slidenum">
               <a:rPr lang="en-US" sz="980" dirty="0">
                 <a:solidFill>
                   <a:srgbClr val="6B7280"/>
@@ -10884,7 +10884,7 @@
           <a:lstStyle/>
           <a:p>
             <a:pPr algn="r"/>
-            <a:fld id="{2C929761-D0AF-4FB6-99A8-F4A205524043}" type="slidenum">
+            <a:fld id="{CE08A4B2-6BE8-42F3-B69C-FA4AB14D774D}" type="slidenum">
               <a:rPr lang="en-US" sz="980" dirty="0">
                 <a:solidFill>
                   <a:srgbClr val="6B7280"/>
@@ -11302,7 +11302,7 @@
           <a:lstStyle/>
           <a:p>
             <a:pPr algn="r"/>
-            <a:fld id="{2C929761-D0AF-4FB6-99A8-F4A205524043}" type="slidenum">
+            <a:fld id="{CE08A4B2-6BE8-42F3-B69C-FA4AB14D774D}" type="slidenum">
               <a:rPr lang="en-US" sz="980" dirty="0">
                 <a:solidFill>
                   <a:srgbClr val="FFFFFF"/>

</xml_diff>